<commit_message>
Publicare 2026-10-18 (versiuni: 2026.1.0)
</commit_message>
<xml_diff>
--- a/UB_MSSS/ro/fisiere/C02.pptx
+++ b/UB_MSSS/ro/fisiere/C02.pptx
@@ -7983,7 +7983,7 @@
                 <a:ea typeface="Palatino Linotype" pitchFamily="34" charset="-122"/>
                 <a:cs typeface="Palatino Linotype" pitchFamily="34" charset="-120"/>
               </a:rPr>
-              <a:t>Sursa: Eurostat, structura populației și proiecția de bază EUROPOP2023. Proiecțiile arată ce s-ar întâmpla dacă ipotezele s-ar confirma.</a:t>
+              <a:t>Sursa: Eurostat, structura populației și proiecția de bază EUROPOP2025. Proiecțiile arată ce s-ar întâmpla dacă ipotezele s-ar confirma.</a:t>
             </a:r>
             <a:endParaRPr lang="en-US" sz="900" dirty="0"/>
           </a:p>
@@ -27226,7 +27226,7 @@
                 <a:ea typeface="Palatino Linotype" pitchFamily="34" charset="-122"/>
                 <a:cs typeface="Palatino Linotype" pitchFamily="34" charset="-120"/>
               </a:rPr>
-              <a:t>Așteptarea la RMN</a:t>
+              <a:t>Așteptarea pentru examenul RMN</a:t>
             </a:r>
             <a:endParaRPr lang="en-US" sz="3400" dirty="0"/>
           </a:p>
@@ -27359,7 +27359,7 @@
                 <a:ea typeface="Palatino Linotype" pitchFamily="34" charset="-122"/>
                 <a:cs typeface="Palatino Linotype" pitchFamily="34" charset="-120"/>
               </a:rPr>
-              <a:t>Medicii de familie semnalează așteptări tot mai lungi la RMN.</a:t>
+              <a:t>Medicii de familie semnalează așteptări tot mai lungi pentru examenul prin rezonanță magnetică (RMN).</a:t>
             </a:r>
             <a:endParaRPr lang="en-US" sz="1450" dirty="0"/>
           </a:p>

</xml_diff>